<commit_message>
fix(slides): add missing DONE state to FSM, remove extra future-work item
</commit_message>
<xml_diff>
--- a/slides/FinalPresentation_FruitSorting.pptx
+++ b/slides/FinalPresentation_FruitSorting.pptx
@@ -8568,7 +8568,20 @@
               </a:defRPr>
             </a:pPr>
             <a:r>
-              <a:t>  ASCEND_PLACE      Lift clear, loop or DONE</a:t>
+              <a:t>  ASCEND_PLACE      Lift clear, loop to SELECT_FRUIT</a:t>
+            </a:r>
+          </a:p>
+          <a:p>
+            <a:pPr algn="l">
+              <a:defRPr sz="800" b="0">
+                <a:solidFill>
+                  <a:srgbClr val="FFFFFF"/>
+                </a:solidFill>
+                <a:latin typeface="Consolas"/>
+              </a:defRPr>
+            </a:pPr>
+            <a:r>
+              <a:t>  DONE              All fruits sorted — return home</a:t>
             </a:r>
           </a:p>
         </p:txBody>
@@ -14605,42 +14618,6 @@
             </a:pPr>
             <a:r>
               <a:t>Parallel sorting for higher throughput</a:t>
-            </a:r>
-          </a:p>
-          <a:p>
-            <a:pPr algn="l">
-              <a:defRPr sz="400" b="0">
-                <a:solidFill>
-                  <a:srgbClr val="FFFFFF"/>
-                </a:solidFill>
-                <a:latin typeface="Calibri"/>
-              </a:defRPr>
-            </a:pPr>
-          </a:p>
-          <a:p>
-            <a:pPr algn="l">
-              <a:defRPr sz="1000" b="1">
-                <a:solidFill>
-                  <a:srgbClr val="FFFFFF"/>
-                </a:solidFill>
-                <a:latin typeface="Calibri"/>
-              </a:defRPr>
-            </a:pPr>
-            <a:r>
-              <a:t>Velocity-Limited Profiles</a:t>
-            </a:r>
-          </a:p>
-          <a:p>
-            <a:pPr algn="l">
-              <a:defRPr sz="900" b="0">
-                <a:solidFill>
-                  <a:srgbClr val="CCCCCC"/>
-                </a:solidFill>
-                <a:latin typeface="Calibri"/>
-              </a:defRPr>
-            </a:pPr>
-            <a:r>
-              <a:t>Trapezoidal trajectories with actuator limits</a:t>
             </a:r>
           </a:p>
         </p:txBody>

</xml_diff>